<commit_message>
Add BioSentinel_X_Complete_System_Audit_Report.pdf audit report
</commit_message>
<xml_diff>
--- a/SIH_2026_MEDORAS_Presentation_Formatted.pptx
+++ b/SIH_2026_MEDORAS_Presentation_Formatted.pptx
@@ -145,7 +145,7 @@
   </p:defaultTextStyle>
   <p:extLst>
     <p:ext uri="{EFAFB233-063F-42B5-8137-9DF3F51BA10A}">
-      <p15:sldGuideLst xmlns:p15="http://schemas.microsoft.com/office/powerpoint/2012/main" xmlns="">
+      <p15:sldGuideLst xmlns="" xmlns:p15="http://schemas.microsoft.com/office/powerpoint/2012/main">
         <p15:guide id="1" orient="horz" pos="2160" userDrawn="1">
           <p15:clr>
             <a:srgbClr val="A4A3A4"/>
@@ -262,7 +262,7 @@
             <a:fld id="{C4D5ADD5-2BBC-4A94-8F86-D9013941F742}" type="datetimeFigureOut">
               <a:rPr lang="en-US"/>
               <a:pPr/>
-              <a:t>8/19/2026</a:t>
+              <a:t>8/23/2026</a:t>
             </a:fld>
             <a:endParaRPr lang="en-US" dirty="0"/>
           </a:p>
@@ -450,7 +450,7 @@
     </p:spTree>
     <p:extLst>
       <p:ext uri="{BB962C8B-B14F-4D97-AF65-F5344CB8AC3E}">
-        <p14:creationId xmlns:p14="http://schemas.microsoft.com/office/powerpoint/2010/main" val="235749454"/>
+        <p14:creationId xmlns:p14="http://schemas.microsoft.com/office/powerpoint/2010/main" xmlns="" val="235749454"/>
       </p:ext>
     </p:extLst>
   </p:cSld>
@@ -689,7 +689,7 @@
     </p:spTree>
     <p:extLst>
       <p:ext uri="{BB962C8B-B14F-4D97-AF65-F5344CB8AC3E}">
-        <p14:creationId xmlns:p14="http://schemas.microsoft.com/office/powerpoint/2010/main" val="2904073229"/>
+        <p14:creationId xmlns:p14="http://schemas.microsoft.com/office/powerpoint/2010/main" xmlns="" val="2904073229"/>
       </p:ext>
     </p:extLst>
   </p:cSld>
@@ -808,7 +808,7 @@
     </p:spTree>
     <p:extLst>
       <p:ext uri="{BB962C8B-B14F-4D97-AF65-F5344CB8AC3E}">
-        <p14:creationId xmlns:p14="http://schemas.microsoft.com/office/powerpoint/2010/main" val="2904073229"/>
+        <p14:creationId xmlns:p14="http://schemas.microsoft.com/office/powerpoint/2010/main" xmlns="" val="2904073229"/>
       </p:ext>
     </p:extLst>
   </p:cSld>
@@ -927,7 +927,7 @@
     </p:spTree>
     <p:extLst>
       <p:ext uri="{BB962C8B-B14F-4D97-AF65-F5344CB8AC3E}">
-        <p14:creationId xmlns:p14="http://schemas.microsoft.com/office/powerpoint/2010/main" val="2904073229"/>
+        <p14:creationId xmlns:p14="http://schemas.microsoft.com/office/powerpoint/2010/main" xmlns="" val="2904073229"/>
       </p:ext>
     </p:extLst>
   </p:cSld>
@@ -1046,7 +1046,7 @@
     </p:spTree>
     <p:extLst>
       <p:ext uri="{BB962C8B-B14F-4D97-AF65-F5344CB8AC3E}">
-        <p14:creationId xmlns:p14="http://schemas.microsoft.com/office/powerpoint/2010/main" val="2904073229"/>
+        <p14:creationId xmlns:p14="http://schemas.microsoft.com/office/powerpoint/2010/main" xmlns="" val="2904073229"/>
       </p:ext>
     </p:extLst>
   </p:cSld>
@@ -1165,7 +1165,7 @@
     </p:spTree>
     <p:extLst>
       <p:ext uri="{BB962C8B-B14F-4D97-AF65-F5344CB8AC3E}">
-        <p14:creationId xmlns:p14="http://schemas.microsoft.com/office/powerpoint/2010/main" val="2904073229"/>
+        <p14:creationId xmlns:p14="http://schemas.microsoft.com/office/powerpoint/2010/main" xmlns="" val="2904073229"/>
       </p:ext>
     </p:extLst>
   </p:cSld>
@@ -1284,7 +1284,7 @@
     </p:spTree>
     <p:extLst>
       <p:ext uri="{BB962C8B-B14F-4D97-AF65-F5344CB8AC3E}">
-        <p14:creationId xmlns:p14="http://schemas.microsoft.com/office/powerpoint/2010/main" val="2904073229"/>
+        <p14:creationId xmlns:p14="http://schemas.microsoft.com/office/powerpoint/2010/main" xmlns="" val="2904073229"/>
       </p:ext>
     </p:extLst>
   </p:cSld>
@@ -1477,7 +1477,8 @@
           <a:p>
             <a:fld id="{E60792E3-D524-454C-8AFD-A91972900BCB}" type="datetime1">
               <a:rPr lang="en-US" smtClean="0"/>
-              <a:t>8/19/2026</a:t>
+              <a:pPr/>
+              <a:t>8/23/2026</a:t>
             </a:fld>
             <a:endParaRPr lang="en-US" dirty="0"/>
           </a:p>
@@ -1659,7 +1660,8 @@
           <a:p>
             <a:fld id="{053C3A68-6922-42D3-8905-ECC2D82A3469}" type="datetime1">
               <a:rPr lang="en-US" smtClean="0"/>
-              <a:t>8/19/2026</a:t>
+              <a:pPr/>
+              <a:t>8/23/2026</a:t>
             </a:fld>
             <a:endParaRPr lang="en-US" dirty="0"/>
           </a:p>
@@ -1851,7 +1853,8 @@
           <a:p>
             <a:fld id="{CB69E9F4-7604-4950-A8B2-8ACDEDB1506E}" type="datetime1">
               <a:rPr lang="en-US" smtClean="0"/>
-              <a:t>8/19/2026</a:t>
+              <a:pPr/>
+              <a:t>8/23/2026</a:t>
             </a:fld>
             <a:endParaRPr lang="en-US" dirty="0"/>
           </a:p>
@@ -2033,7 +2036,8 @@
           <a:p>
             <a:fld id="{708B7524-32A2-4C20-A58C-BC3BAA1042FC}" type="datetime1">
               <a:rPr lang="en-US" smtClean="0"/>
-              <a:t>8/19/2026</a:t>
+              <a:pPr/>
+              <a:t>8/23/2026</a:t>
             </a:fld>
             <a:endParaRPr lang="en-US" dirty="0"/>
           </a:p>
@@ -2292,7 +2296,8 @@
           <a:p>
             <a:fld id="{1E994447-D6B2-43BB-A877-57F1A267B999}" type="datetime1">
               <a:rPr lang="en-US" smtClean="0"/>
-              <a:t>8/19/2026</a:t>
+              <a:pPr/>
+              <a:t>8/23/2026</a:t>
             </a:fld>
             <a:endParaRPr lang="en-US" dirty="0"/>
           </a:p>
@@ -2591,7 +2596,8 @@
           <a:p>
             <a:fld id="{68920E16-BD35-483C-AA6B-346FC7E46DEA}" type="datetime1">
               <a:rPr lang="en-US" smtClean="0"/>
-              <a:t>8/19/2026</a:t>
+              <a:pPr/>
+              <a:t>8/23/2026</a:t>
             </a:fld>
             <a:endParaRPr lang="en-US" dirty="0"/>
           </a:p>
@@ -3024,7 +3030,8 @@
           <a:p>
             <a:fld id="{2FEAC6F8-5103-4FC0-A69E-5C6AE6469DA8}" type="datetime1">
               <a:rPr lang="en-US" smtClean="0"/>
-              <a:t>8/19/2026</a:t>
+              <a:pPr/>
+              <a:t>8/23/2026</a:t>
             </a:fld>
             <a:endParaRPr lang="en-US" dirty="0"/>
           </a:p>
@@ -3155,7 +3162,8 @@
           <a:p>
             <a:fld id="{C60C6921-0627-4C8F-83D5-0CF936D2FFDD}" type="datetime1">
               <a:rPr lang="en-US" smtClean="0"/>
-              <a:t>8/19/2026</a:t>
+              <a:pPr/>
+              <a:t>8/23/2026</a:t>
             </a:fld>
             <a:endParaRPr lang="en-US" dirty="0"/>
           </a:p>
@@ -3264,7 +3272,8 @@
           <a:p>
             <a:fld id="{2FF08AD7-8103-40F8-983C-E2BA6BB9CBE0}" type="datetime1">
               <a:rPr lang="en-US" smtClean="0"/>
-              <a:t>8/19/2026</a:t>
+              <a:pPr/>
+              <a:t>8/23/2026</a:t>
             </a:fld>
             <a:endParaRPr lang="en-US" dirty="0"/>
           </a:p>
@@ -3553,7 +3562,8 @@
           <a:p>
             <a:fld id="{DF8C06B4-9380-4A4D-AF49-A3596E17DAF5}" type="datetime1">
               <a:rPr lang="en-US" smtClean="0"/>
-              <a:t>8/19/2026</a:t>
+              <a:pPr/>
+              <a:t>8/23/2026</a:t>
             </a:fld>
             <a:endParaRPr lang="en-US" dirty="0"/>
           </a:p>
@@ -3822,7 +3832,8 @@
           <a:p>
             <a:fld id="{EF7FDEF1-C582-4E22-9E77-D68326471F28}" type="datetime1">
               <a:rPr lang="en-US" smtClean="0"/>
-              <a:t>8/19/2026</a:t>
+              <a:pPr/>
+              <a:t>8/23/2026</a:t>
             </a:fld>
             <a:endParaRPr lang="en-US" dirty="0"/>
           </a:p>
@@ -4065,7 +4076,8 @@
           <a:p>
             <a:fld id="{780A9602-A9A9-453F-AEF1-37B5837E02CD}" type="datetime1">
               <a:rPr lang="en-US" smtClean="0"/>
-              <a:t>8/19/2026</a:t>
+              <a:pPr/>
+              <a:t>8/23/2026</a:t>
             </a:fld>
             <a:endParaRPr lang="en-US" dirty="0"/>
           </a:p>
@@ -4613,7 +4625,7 @@
           <p:cNvPr id="5" name="Picture 4">
             <a:extLst>
               <a:ext uri="{FF2B5EF4-FFF2-40B4-BE49-F238E27FC236}">
-                <a16:creationId xmlns:a16="http://schemas.microsoft.com/office/drawing/2014/main" xmlns="" id="{9120848B-B2B4-45BE-A961-AEC0B06CF41B}"/>
+                <a16:creationId xmlns="" xmlns:a16="http://schemas.microsoft.com/office/drawing/2014/main" id="{9120848B-B2B4-45BE-A961-AEC0B06CF41B}"/>
               </a:ext>
             </a:extLst>
           </p:cNvPr>
@@ -4663,7 +4675,7 @@
               <a:spcAft>
                 <a:spcPts val="800"/>
               </a:spcAft>
-              <a:defRPr b="1" sz="2800">
+              <a:defRPr sz="2800" b="1">
                 <a:solidFill>
                   <a:srgbClr val="0F172A"/>
                 </a:solidFill>
@@ -4679,7 +4691,7 @@
               <a:spcAft>
                 <a:spcPts val="1600"/>
               </a:spcAft>
-              <a:defRPr b="1" sz="1600">
+              <a:defRPr sz="1600" b="1">
                 <a:solidFill>
                   <a:srgbClr val="0891B2"/>
                 </a:solidFill>
@@ -4697,7 +4709,7 @@
               </a:spcAft>
             </a:pPr>
             <a:r>
-              <a:rPr b="1" sz="1500">
+              <a:rPr sz="1500" b="1">
                 <a:solidFill>
                   <a:srgbClr val="0891B2"/>
                 </a:solidFill>
@@ -4706,7 +4718,7 @@
               <a:t>• Problem Statement ID: </a:t>
             </a:r>
             <a:r>
-              <a:rPr b="0" sz="1500">
+              <a:rPr sz="1500" b="0">
                 <a:solidFill>
                   <a:srgbClr val="1E293B"/>
                 </a:solidFill>
@@ -4722,7 +4734,7 @@
               </a:spcAft>
             </a:pPr>
             <a:r>
-              <a:rPr b="1" sz="1500">
+              <a:rPr sz="1500" b="1">
                 <a:solidFill>
                   <a:srgbClr val="0891B2"/>
                 </a:solidFill>
@@ -4731,7 +4743,7 @@
               <a:t>• Problem Statement Title: </a:t>
             </a:r>
             <a:r>
-              <a:rPr b="0" sz="1500">
+              <a:rPr sz="1500" b="0">
                 <a:solidFill>
                   <a:srgbClr val="1E293B"/>
                 </a:solidFill>
@@ -4747,7 +4759,7 @@
               </a:spcAft>
             </a:pPr>
             <a:r>
-              <a:rPr b="1" sz="1500">
+              <a:rPr sz="1500" b="1">
                 <a:solidFill>
                   <a:srgbClr val="0891B2"/>
                 </a:solidFill>
@@ -4756,7 +4768,7 @@
               <a:t>• Theme &amp; Category: </a:t>
             </a:r>
             <a:r>
-              <a:rPr b="0" sz="1500">
+              <a:rPr sz="1500" b="0">
                 <a:solidFill>
                   <a:srgbClr val="1E293B"/>
                 </a:solidFill>
@@ -4772,7 +4784,7 @@
               </a:spcAft>
             </a:pPr>
             <a:r>
-              <a:rPr b="1" sz="1500">
+              <a:rPr sz="1500" b="1">
                 <a:solidFill>
                   <a:srgbClr val="0891B2"/>
                 </a:solidFill>
@@ -4781,7 +4793,7 @@
               <a:t>• Team Name &amp; ID: </a:t>
             </a:r>
             <a:r>
-              <a:rPr b="0" sz="1500">
+              <a:rPr sz="1500" b="0">
                 <a:solidFill>
                   <a:srgbClr val="1E293B"/>
                 </a:solidFill>
@@ -4797,7 +4809,7 @@
               </a:spcAft>
             </a:pPr>
             <a:r>
-              <a:rPr b="1" sz="1500">
+              <a:rPr sz="1500" b="1">
                 <a:solidFill>
                   <a:srgbClr val="0891B2"/>
                 </a:solidFill>
@@ -4806,7 +4818,7 @@
               <a:t>• Tagline: </a:t>
             </a:r>
             <a:r>
-              <a:rPr b="0" sz="1500">
+              <a:rPr sz="1500" b="0">
                 <a:solidFill>
                   <a:srgbClr val="1E293B"/>
                 </a:solidFill>
@@ -4822,7 +4834,7 @@
               </a:spcAft>
             </a:pPr>
             <a:r>
-              <a:rPr b="1" sz="1500">
+              <a:rPr sz="1500" b="1">
                 <a:solidFill>
                   <a:srgbClr val="0891B2"/>
                 </a:solidFill>
@@ -4831,7 +4843,7 @@
               <a:t>• Core Principle: </a:t>
             </a:r>
             <a:r>
-              <a:rPr b="0" sz="1500">
+              <a:rPr sz="1500" b="0">
                 <a:solidFill>
                   <a:srgbClr val="1E293B"/>
                 </a:solidFill>
@@ -4879,7 +4891,7 @@
           <a:blip r:embed="rId3">
             <a:extLst>
               <a:ext uri="{28A0092B-C50C-407E-A947-70E740481C1C}">
-                <a14:useLocalDpi xmlns:a14="http://schemas.microsoft.com/office/drawing/2010/main" val="0"/>
+                <a14:useLocalDpi xmlns:a14="http://schemas.microsoft.com/office/drawing/2010/main" xmlns="" val="0"/>
               </a:ext>
             </a:extLst>
           </a:blip>
@@ -4903,14 +4915,14 @@
           <a:effectLst/>
           <a:extLst>
             <a:ext uri="{909E8E84-426E-40DD-AFC4-6F175D3DCCD1}">
-              <a14:hiddenFill xmlns:a14="http://schemas.microsoft.com/office/drawing/2010/main">
+              <a14:hiddenFill xmlns:a14="http://schemas.microsoft.com/office/drawing/2010/main" xmlns="">
                 <a:solidFill>
                   <a:schemeClr val="accent1"/>
                 </a:solidFill>
               </a14:hiddenFill>
             </a:ext>
             <a:ext uri="{91240B29-F687-4F45-9708-019B960494DF}">
-              <a14:hiddenLine xmlns:a14="http://schemas.microsoft.com/office/drawing/2010/main" w="9525">
+              <a14:hiddenLine xmlns:a14="http://schemas.microsoft.com/office/drawing/2010/main" xmlns="" w="9525">
                 <a:solidFill>
                   <a:schemeClr val="tx1"/>
                 </a:solidFill>
@@ -4920,7 +4932,7 @@
               </a14:hiddenLine>
             </a:ext>
             <a:ext uri="{AF507438-7753-43E0-B8FC-AC1667EBCBE1}">
-              <a14:hiddenEffects xmlns:a14="http://schemas.microsoft.com/office/drawing/2010/main">
+              <a14:hiddenEffects xmlns:a14="http://schemas.microsoft.com/office/drawing/2010/main" xmlns="">
                 <a:effectLst>
                   <a:outerShdw dist="35921" dir="2700000" algn="ctr" rotWithShape="0">
                     <a:schemeClr val="bg2"/>
@@ -4957,7 +4969,7 @@
               <a:spcAft>
                 <a:spcPts val="800"/>
               </a:spcAft>
-              <a:defRPr b="1" sz="2800">
+              <a:defRPr sz="2800" b="1">
                 <a:solidFill>
                   <a:srgbClr val="0F172A"/>
                 </a:solidFill>
@@ -4975,7 +4987,7 @@
               </a:spcAft>
             </a:pPr>
             <a:r>
-              <a:rPr b="1" sz="1500">
+              <a:rPr sz="1500" b="1">
                 <a:solidFill>
                   <a:srgbClr val="0891B2"/>
                 </a:solidFill>
@@ -4983,7 +4995,7 @@
               <a:t>• </a:t>
             </a:r>
             <a:r>
-              <a:rPr b="1" sz="1500">
+              <a:rPr sz="1500" b="1">
                 <a:solidFill>
                   <a:srgbClr val="0F172A"/>
                 </a:solidFill>
@@ -4992,7 +5004,7 @@
               <a:t>Object-First Perception: </a:t>
             </a:r>
             <a:r>
-              <a:rPr b="0" sz="1400">
+              <a:rPr sz="1400" b="0">
                 <a:solidFill>
                   <a:srgbClr val="1E293B"/>
                 </a:solidFill>
@@ -5008,7 +5020,7 @@
               </a:spcAft>
             </a:pPr>
             <a:r>
-              <a:rPr b="1" sz="1500">
+              <a:rPr sz="1500" b="1">
                 <a:solidFill>
                   <a:srgbClr val="0891B2"/>
                 </a:solidFill>
@@ -5016,7 +5028,7 @@
               <a:t>• </a:t>
             </a:r>
             <a:r>
-              <a:rPr b="1" sz="1500">
+              <a:rPr sz="1500" b="1">
                 <a:solidFill>
                   <a:srgbClr val="0F172A"/>
                 </a:solidFill>
@@ -5025,7 +5037,7 @@
               <a:t>Deterministic Stream Mapping: </a:t>
             </a:r>
             <a:r>
-              <a:rPr b="0" sz="1400">
+              <a:rPr sz="1400" b="0">
                 <a:solidFill>
                   <a:srgbClr val="1E293B"/>
                 </a:solidFill>
@@ -5041,7 +5053,7 @@
               </a:spcAft>
             </a:pPr>
             <a:r>
-              <a:rPr b="1" sz="1500">
+              <a:rPr sz="1500" b="1">
                 <a:solidFill>
                   <a:srgbClr val="0891B2"/>
                 </a:solidFill>
@@ -5049,7 +5061,7 @@
               <a:t>• </a:t>
             </a:r>
             <a:r>
-              <a:rPr b="1" sz="1500">
+              <a:rPr sz="1500" b="1">
                 <a:solidFill>
                   <a:srgbClr val="0F172A"/>
                 </a:solidFill>
@@ -5058,7 +5070,7 @@
               <a:t>Real-Time Camera Integration: </a:t>
             </a:r>
             <a:r>
-              <a:rPr b="0" sz="1400">
+              <a:rPr sz="1400" b="0">
                 <a:solidFill>
                   <a:srgbClr val="1E293B"/>
                 </a:solidFill>
@@ -5074,7 +5086,7 @@
               </a:spcAft>
             </a:pPr>
             <a:r>
-              <a:rPr b="1" sz="1500">
+              <a:rPr sz="1500" b="1">
                 <a:solidFill>
                   <a:srgbClr val="0891B2"/>
                 </a:solidFill>
@@ -5082,7 +5094,7 @@
               <a:t>• </a:t>
             </a:r>
             <a:r>
-              <a:rPr b="1" sz="1500">
+              <a:rPr sz="1500" b="1">
                 <a:solidFill>
                   <a:srgbClr val="0F172A"/>
                 </a:solidFill>
@@ -5091,7 +5103,7 @@
               <a:t>End-to-End Tracking: </a:t>
             </a:r>
             <a:r>
-              <a:rPr b="0" sz="1400">
+              <a:rPr sz="1400" b="0">
                 <a:solidFill>
                   <a:srgbClr val="1E293B"/>
                 </a:solidFill>
@@ -5107,7 +5119,7 @@
               </a:spcAft>
             </a:pPr>
             <a:r>
-              <a:rPr b="1" sz="1500">
+              <a:rPr sz="1500" b="1">
                 <a:solidFill>
                   <a:srgbClr val="0891B2"/>
                 </a:solidFill>
@@ -5115,7 +5127,7 @@
               <a:t>• </a:t>
             </a:r>
             <a:r>
-              <a:rPr b="1" sz="1500">
+              <a:rPr sz="1500" b="1">
                 <a:solidFill>
                   <a:srgbClr val="0F172A"/>
                 </a:solidFill>
@@ -5124,7 +5136,7 @@
               <a:t>Hardware-Ready Architecture: </a:t>
             </a:r>
             <a:r>
-              <a:rPr b="0" sz="1400">
+              <a:rPr sz="1400" b="0">
                 <a:solidFill>
                   <a:srgbClr val="1E293B"/>
                 </a:solidFill>
@@ -5172,7 +5184,7 @@
           <a:blip r:embed="rId3">
             <a:extLst>
               <a:ext uri="{28A0092B-C50C-407E-A947-70E740481C1C}">
-                <a14:useLocalDpi xmlns:a14="http://schemas.microsoft.com/office/drawing/2010/main" val="0"/>
+                <a14:useLocalDpi xmlns:a14="http://schemas.microsoft.com/office/drawing/2010/main" xmlns="" val="0"/>
               </a:ext>
             </a:extLst>
           </a:blip>
@@ -5196,14 +5208,14 @@
           <a:effectLst/>
           <a:extLst>
             <a:ext uri="{909E8E84-426E-40DD-AFC4-6F175D3DCCD1}">
-              <a14:hiddenFill xmlns:a14="http://schemas.microsoft.com/office/drawing/2010/main">
+              <a14:hiddenFill xmlns:a14="http://schemas.microsoft.com/office/drawing/2010/main" xmlns="">
                 <a:solidFill>
                   <a:schemeClr val="accent1"/>
                 </a:solidFill>
               </a14:hiddenFill>
             </a:ext>
             <a:ext uri="{91240B29-F687-4F45-9708-019B960494DF}">
-              <a14:hiddenLine xmlns:a14="http://schemas.microsoft.com/office/drawing/2010/main" w="9525">
+              <a14:hiddenLine xmlns:a14="http://schemas.microsoft.com/office/drawing/2010/main" xmlns="" w="9525">
                 <a:solidFill>
                   <a:schemeClr val="tx1"/>
                 </a:solidFill>
@@ -5213,7 +5225,7 @@
               </a14:hiddenLine>
             </a:ext>
             <a:ext uri="{AF507438-7753-43E0-B8FC-AC1667EBCBE1}">
-              <a14:hiddenEffects xmlns:a14="http://schemas.microsoft.com/office/drawing/2010/main">
+              <a14:hiddenEffects xmlns:a14="http://schemas.microsoft.com/office/drawing/2010/main" xmlns="">
                 <a:effectLst>
                   <a:outerShdw dist="35921" dir="2700000" algn="ctr" rotWithShape="0">
                     <a:schemeClr val="bg2"/>
@@ -5250,7 +5262,7 @@
               <a:spcAft>
                 <a:spcPts val="800"/>
               </a:spcAft>
-              <a:defRPr b="1" sz="2800">
+              <a:defRPr sz="2800" b="1">
                 <a:solidFill>
                   <a:srgbClr val="0F172A"/>
                 </a:solidFill>
@@ -5268,7 +5280,7 @@
               </a:spcAft>
             </a:pPr>
             <a:r>
-              <a:rPr b="1" sz="1500">
+              <a:rPr sz="1500" b="1">
                 <a:solidFill>
                   <a:srgbClr val="0891B2"/>
                 </a:solidFill>
@@ -5276,7 +5288,7 @@
               <a:t>• </a:t>
             </a:r>
             <a:r>
-              <a:rPr b="1" sz="1500">
+              <a:rPr sz="1500" b="1">
                 <a:solidFill>
                   <a:srgbClr val="0F172A"/>
                 </a:solidFill>
@@ -5285,7 +5297,7 @@
               <a:t>Prediction ≠ Permission: </a:t>
             </a:r>
             <a:r>
-              <a:rPr b="0" sz="1400">
+              <a:rPr sz="1400" b="0">
                 <a:solidFill>
                   <a:srgbClr val="1E293B"/>
                 </a:solidFill>
@@ -5301,7 +5313,7 @@
               </a:spcAft>
             </a:pPr>
             <a:r>
-              <a:rPr b="1" sz="1500">
+              <a:rPr sz="1500" b="1">
                 <a:solidFill>
                   <a:srgbClr val="0891B2"/>
                 </a:solidFill>
@@ -5309,7 +5321,7 @@
               <a:t>• </a:t>
             </a:r>
             <a:r>
-              <a:rPr b="1" sz="1500">
+              <a:rPr sz="1500" b="1">
                 <a:solidFill>
                   <a:srgbClr val="0F172A"/>
                 </a:solidFill>
@@ -5318,7 +5330,7 @@
               <a:t>Critical Hazard Gate: </a:t>
             </a:r>
             <a:r>
-              <a:rPr b="0" sz="1400">
+              <a:rPr sz="1400" b="0">
                 <a:solidFill>
                   <a:srgbClr val="1E293B"/>
                 </a:solidFill>
@@ -5334,7 +5346,7 @@
               </a:spcAft>
             </a:pPr>
             <a:r>
-              <a:rPr b="1" sz="1500">
+              <a:rPr sz="1500" b="1">
                 <a:solidFill>
                   <a:srgbClr val="0891B2"/>
                 </a:solidFill>
@@ -5342,7 +5354,7 @@
               <a:t>• </a:t>
             </a:r>
             <a:r>
-              <a:rPr b="1" sz="1500">
+              <a:rPr sz="1500" b="1">
                 <a:solidFill>
                   <a:srgbClr val="0F172A"/>
                 </a:solidFill>
@@ -5351,7 +5363,7 @@
               <a:t>8-Level Deterministic Policy: </a:t>
             </a:r>
             <a:r>
-              <a:rPr b="0" sz="1400">
+              <a:rPr sz="1400" b="0">
                 <a:solidFill>
                   <a:srgbClr val="1E293B"/>
                 </a:solidFill>
@@ -5367,7 +5379,7 @@
               </a:spcAft>
             </a:pPr>
             <a:r>
-              <a:rPr b="1" sz="1500">
+              <a:rPr sz="1500" b="1">
                 <a:solidFill>
                   <a:srgbClr val="0891B2"/>
                 </a:solidFill>
@@ -5375,7 +5387,7 @@
               <a:t>• </a:t>
             </a:r>
             <a:r>
-              <a:rPr b="1" sz="1500">
+              <a:rPr sz="1500" b="1">
                 <a:solidFill>
                   <a:srgbClr val="0F172A"/>
                 </a:solidFill>
@@ -5384,7 +5396,7 @@
               <a:t>SHA-256 Cryptographic Audit: </a:t>
             </a:r>
             <a:r>
-              <a:rPr b="0" sz="1400">
+              <a:rPr sz="1400" b="0">
                 <a:solidFill>
                   <a:srgbClr val="1E293B"/>
                 </a:solidFill>
@@ -5400,7 +5412,7 @@
               </a:spcAft>
             </a:pPr>
             <a:r>
-              <a:rPr b="1" sz="1500">
+              <a:rPr sz="1500" b="1">
                 <a:solidFill>
                   <a:srgbClr val="0891B2"/>
                 </a:solidFill>
@@ -5408,7 +5420,7 @@
               <a:t>• </a:t>
             </a:r>
             <a:r>
-              <a:rPr b="1" sz="1500">
+              <a:rPr sz="1500" b="1">
                 <a:solidFill>
                   <a:srgbClr val="0F172A"/>
                 </a:solidFill>
@@ -5417,7 +5429,7 @@
               <a:t>Verifier Retraining Loop: </a:t>
             </a:r>
             <a:r>
-              <a:rPr b="0" sz="1400">
+              <a:rPr sz="1400" b="0">
                 <a:solidFill>
                   <a:srgbClr val="1E293B"/>
                 </a:solidFill>
@@ -5431,7 +5443,7 @@
     </p:spTree>
     <p:extLst>
       <p:ext uri="{BB962C8B-B14F-4D97-AF65-F5344CB8AC3E}">
-        <p14:creationId xmlns:p14="http://schemas.microsoft.com/office/powerpoint/2010/main" val="3360916516"/>
+        <p14:creationId xmlns:p14="http://schemas.microsoft.com/office/powerpoint/2010/main" xmlns="" val="3360916516"/>
       </p:ext>
     </p:extLst>
   </p:cSld>
@@ -5470,7 +5482,7 @@
           <a:blip r:embed="rId3">
             <a:extLst>
               <a:ext uri="{28A0092B-C50C-407E-A947-70E740481C1C}">
-                <a14:useLocalDpi xmlns:a14="http://schemas.microsoft.com/office/drawing/2010/main" val="0"/>
+                <a14:useLocalDpi xmlns:a14="http://schemas.microsoft.com/office/drawing/2010/main" xmlns="" val="0"/>
               </a:ext>
             </a:extLst>
           </a:blip>
@@ -5494,14 +5506,14 @@
           <a:effectLst/>
           <a:extLst>
             <a:ext uri="{909E8E84-426E-40DD-AFC4-6F175D3DCCD1}">
-              <a14:hiddenFill xmlns:a14="http://schemas.microsoft.com/office/drawing/2010/main">
+              <a14:hiddenFill xmlns:a14="http://schemas.microsoft.com/office/drawing/2010/main" xmlns="">
                 <a:solidFill>
                   <a:schemeClr val="accent1"/>
                 </a:solidFill>
               </a14:hiddenFill>
             </a:ext>
             <a:ext uri="{91240B29-F687-4F45-9708-019B960494DF}">
-              <a14:hiddenLine xmlns:a14="http://schemas.microsoft.com/office/drawing/2010/main" w="9525">
+              <a14:hiddenLine xmlns:a14="http://schemas.microsoft.com/office/drawing/2010/main" xmlns="" w="9525">
                 <a:solidFill>
                   <a:schemeClr val="tx1"/>
                 </a:solidFill>
@@ -5511,7 +5523,7 @@
               </a14:hiddenLine>
             </a:ext>
             <a:ext uri="{AF507438-7753-43E0-B8FC-AC1667EBCBE1}">
-              <a14:hiddenEffects xmlns:a14="http://schemas.microsoft.com/office/drawing/2010/main">
+              <a14:hiddenEffects xmlns:a14="http://schemas.microsoft.com/office/drawing/2010/main" xmlns="">
                 <a:effectLst>
                   <a:outerShdw dist="35921" dir="2700000" algn="ctr" rotWithShape="0">
                     <a:schemeClr val="bg2"/>
@@ -5548,7 +5560,7 @@
               <a:spcAft>
                 <a:spcPts val="800"/>
               </a:spcAft>
-              <a:defRPr b="1" sz="2800">
+              <a:defRPr sz="2800" b="1">
                 <a:solidFill>
                   <a:srgbClr val="0F172A"/>
                 </a:solidFill>
@@ -5566,7 +5578,7 @@
               </a:spcAft>
             </a:pPr>
             <a:r>
-              <a:rPr b="1" sz="1500">
+              <a:rPr sz="1500" b="1">
                 <a:solidFill>
                   <a:srgbClr val="0891B2"/>
                 </a:solidFill>
@@ -5574,7 +5586,7 @@
               <a:t>• </a:t>
             </a:r>
             <a:r>
-              <a:rPr b="1" sz="1500">
+              <a:rPr sz="1500" b="1">
                 <a:solidFill>
                   <a:srgbClr val="0F172A"/>
                 </a:solidFill>
@@ -5583,7 +5595,7 @@
               <a:t>AI Perception Stack: </a:t>
             </a:r>
             <a:r>
-              <a:rPr b="0" sz="1400">
+              <a:rPr sz="1400" b="0">
                 <a:solidFill>
                   <a:srgbClr val="1E293B"/>
                 </a:solidFill>
@@ -5599,7 +5611,7 @@
               </a:spcAft>
             </a:pPr>
             <a:r>
-              <a:rPr b="1" sz="1500">
+              <a:rPr sz="1500" b="1">
                 <a:solidFill>
                   <a:srgbClr val="0891B2"/>
                 </a:solidFill>
@@ -5607,7 +5619,7 @@
               <a:t>• </a:t>
             </a:r>
             <a:r>
-              <a:rPr b="1" sz="1500">
+              <a:rPr sz="1500" b="1">
                 <a:solidFill>
                   <a:srgbClr val="0F172A"/>
                 </a:solidFill>
@@ -5616,7 +5628,7 @@
               <a:t>True AI Metrics: </a:t>
             </a:r>
             <a:r>
-              <a:rPr b="0" sz="1400">
+              <a:rPr sz="1400" b="0">
                 <a:solidFill>
                   <a:srgbClr val="1E293B"/>
                 </a:solidFill>
@@ -5632,7 +5644,7 @@
               </a:spcAft>
             </a:pPr>
             <a:r>
-              <a:rPr b="1" sz="1500">
+              <a:rPr sz="1500" b="1">
                 <a:solidFill>
                   <a:srgbClr val="0891B2"/>
                 </a:solidFill>
@@ -5640,7 +5652,7 @@
               <a:t>• </a:t>
             </a:r>
             <a:r>
-              <a:rPr b="1" sz="1500">
+              <a:rPr sz="1500" b="1">
                 <a:solidFill>
                   <a:srgbClr val="0F172A"/>
                 </a:solidFill>
@@ -5649,7 +5661,7 @@
               <a:t>Per-Class Accuracy: </a:t>
             </a:r>
             <a:r>
-              <a:rPr b="0" sz="1400">
+              <a:rPr sz="1400" b="0">
                 <a:solidFill>
                   <a:srgbClr val="1E293B"/>
                 </a:solidFill>
@@ -5665,7 +5677,7 @@
               </a:spcAft>
             </a:pPr>
             <a:r>
-              <a:rPr b="1" sz="1500">
+              <a:rPr sz="1500" b="1">
                 <a:solidFill>
                   <a:srgbClr val="0891B2"/>
                 </a:solidFill>
@@ -5673,7 +5685,7 @@
               <a:t>• </a:t>
             </a:r>
             <a:r>
-              <a:rPr b="1" sz="1500">
+              <a:rPr sz="1500" b="1">
                 <a:solidFill>
                   <a:srgbClr val="0F172A"/>
                 </a:solidFill>
@@ -5682,7 +5694,7 @@
               <a:t>Full-Stack Architecture: </a:t>
             </a:r>
             <a:r>
-              <a:rPr b="0" sz="1400">
+              <a:rPr sz="1400" b="0">
                 <a:solidFill>
                   <a:srgbClr val="1E293B"/>
                 </a:solidFill>
@@ -5698,7 +5710,7 @@
               </a:spcAft>
             </a:pPr>
             <a:r>
-              <a:rPr b="1" sz="1500">
+              <a:rPr sz="1500" b="1">
                 <a:solidFill>
                   <a:srgbClr val="0891B2"/>
                 </a:solidFill>
@@ -5706,7 +5718,7 @@
               <a:t>• </a:t>
             </a:r>
             <a:r>
-              <a:rPr b="1" sz="1500">
+              <a:rPr sz="1500" b="1">
                 <a:solidFill>
                   <a:srgbClr val="0F172A"/>
                 </a:solidFill>
@@ -5715,7 +5727,7 @@
               <a:t>Safety Verification: </a:t>
             </a:r>
             <a:r>
-              <a:rPr b="0" sz="1400">
+              <a:rPr sz="1400" b="0">
                 <a:solidFill>
                   <a:srgbClr val="1E293B"/>
                 </a:solidFill>
@@ -5729,7 +5741,7 @@
     </p:spTree>
     <p:extLst>
       <p:ext uri="{BB962C8B-B14F-4D97-AF65-F5344CB8AC3E}">
-        <p14:creationId xmlns:p14="http://schemas.microsoft.com/office/powerpoint/2010/main" val="1912483354"/>
+        <p14:creationId xmlns:p14="http://schemas.microsoft.com/office/powerpoint/2010/main" xmlns="" val="1912483354"/>
       </p:ext>
     </p:extLst>
   </p:cSld>
@@ -5768,7 +5780,7 @@
           <a:blip r:embed="rId3">
             <a:extLst>
               <a:ext uri="{28A0092B-C50C-407E-A947-70E740481C1C}">
-                <a14:useLocalDpi xmlns:a14="http://schemas.microsoft.com/office/drawing/2010/main" val="0"/>
+                <a14:useLocalDpi xmlns:a14="http://schemas.microsoft.com/office/drawing/2010/main" xmlns="" val="0"/>
               </a:ext>
             </a:extLst>
           </a:blip>
@@ -5792,14 +5804,14 @@
           <a:effectLst/>
           <a:extLst>
             <a:ext uri="{909E8E84-426E-40DD-AFC4-6F175D3DCCD1}">
-              <a14:hiddenFill xmlns:a14="http://schemas.microsoft.com/office/drawing/2010/main">
+              <a14:hiddenFill xmlns:a14="http://schemas.microsoft.com/office/drawing/2010/main" xmlns="">
                 <a:solidFill>
                   <a:schemeClr val="accent1"/>
                 </a:solidFill>
               </a14:hiddenFill>
             </a:ext>
             <a:ext uri="{91240B29-F687-4F45-9708-019B960494DF}">
-              <a14:hiddenLine xmlns:a14="http://schemas.microsoft.com/office/drawing/2010/main" w="9525">
+              <a14:hiddenLine xmlns:a14="http://schemas.microsoft.com/office/drawing/2010/main" xmlns="" w="9525">
                 <a:solidFill>
                   <a:schemeClr val="tx1"/>
                 </a:solidFill>
@@ -5809,7 +5821,7 @@
               </a14:hiddenLine>
             </a:ext>
             <a:ext uri="{AF507438-7753-43E0-B8FC-AC1667EBCBE1}">
-              <a14:hiddenEffects xmlns:a14="http://schemas.microsoft.com/office/drawing/2010/main">
+              <a14:hiddenEffects xmlns:a14="http://schemas.microsoft.com/office/drawing/2010/main" xmlns="">
                 <a:effectLst>
                   <a:outerShdw dist="35921" dir="2700000" algn="ctr" rotWithShape="0">
                     <a:schemeClr val="bg2"/>
@@ -5846,7 +5858,7 @@
               <a:spcAft>
                 <a:spcPts val="800"/>
               </a:spcAft>
-              <a:defRPr b="1" sz="2800">
+              <a:defRPr sz="2800" b="1">
                 <a:solidFill>
                   <a:srgbClr val="0F172A"/>
                 </a:solidFill>
@@ -5864,7 +5876,7 @@
               </a:spcAft>
             </a:pPr>
             <a:r>
-              <a:rPr b="1" sz="1500">
+              <a:rPr sz="1500" b="1">
                 <a:solidFill>
                   <a:srgbClr val="0891B2"/>
                 </a:solidFill>
@@ -5872,7 +5884,7 @@
               <a:t>• </a:t>
             </a:r>
             <a:r>
-              <a:rPr b="1" sz="1500">
+              <a:rPr sz="1500" b="1">
                 <a:solidFill>
                   <a:srgbClr val="0F172A"/>
                 </a:solidFill>
@@ -5881,7 +5893,7 @@
               <a:t>Indian Market Scale: </a:t>
             </a:r>
             <a:r>
-              <a:rPr b="0" sz="1400">
+              <a:rPr sz="1400" b="0">
                 <a:solidFill>
                   <a:srgbClr val="1E293B"/>
                 </a:solidFill>
@@ -5897,7 +5909,7 @@
               </a:spcAft>
             </a:pPr>
             <a:r>
-              <a:rPr b="1" sz="1500">
+              <a:rPr sz="1500" b="1">
                 <a:solidFill>
                   <a:srgbClr val="0891B2"/>
                 </a:solidFill>
@@ -5905,7 +5917,7 @@
               <a:t>• </a:t>
             </a:r>
             <a:r>
-              <a:rPr b="1" sz="1500">
+              <a:rPr sz="1500" b="1">
                 <a:solidFill>
                   <a:srgbClr val="0F172A"/>
                 </a:solidFill>
@@ -5914,7 +5926,7 @@
               <a:t>Occupational Safety: </a:t>
             </a:r>
             <a:r>
-              <a:rPr b="0" sz="1400">
+              <a:rPr sz="1400" b="0">
                 <a:solidFill>
                   <a:srgbClr val="1E293B"/>
                 </a:solidFill>
@@ -5930,7 +5942,7 @@
               </a:spcAft>
             </a:pPr>
             <a:r>
-              <a:rPr b="1" sz="1500">
+              <a:rPr sz="1500" b="1">
                 <a:solidFill>
                   <a:srgbClr val="0891B2"/>
                 </a:solidFill>
@@ -5938,7 +5950,7 @@
               <a:t>• </a:t>
             </a:r>
             <a:r>
-              <a:rPr b="1" sz="1500">
+              <a:rPr sz="1500" b="1">
                 <a:solidFill>
                   <a:srgbClr val="0F172A"/>
                 </a:solidFill>
@@ -5947,7 +5959,7 @@
               <a:t>Financial Cost Savings: </a:t>
             </a:r>
             <a:r>
-              <a:rPr b="0" sz="1400">
+              <a:rPr sz="1400" b="0">
                 <a:solidFill>
                   <a:srgbClr val="1E293B"/>
                 </a:solidFill>
@@ -5963,7 +5975,7 @@
               </a:spcAft>
             </a:pPr>
             <a:r>
-              <a:rPr b="1" sz="1500">
+              <a:rPr sz="1500" b="1">
                 <a:solidFill>
                   <a:srgbClr val="0891B2"/>
                 </a:solidFill>
@@ -5971,7 +5983,7 @@
               <a:t>• </a:t>
             </a:r>
             <a:r>
-              <a:rPr b="1" sz="1500">
+              <a:rPr sz="1500" b="1">
                 <a:solidFill>
                   <a:srgbClr val="0F172A"/>
                 </a:solidFill>
@@ -5980,7 +5992,7 @@
               <a:t>System Scalability: </a:t>
             </a:r>
             <a:r>
-              <a:rPr b="0" sz="1400">
+              <a:rPr sz="1400" b="0">
                 <a:solidFill>
                   <a:srgbClr val="1E293B"/>
                 </a:solidFill>
@@ -5996,7 +6008,7 @@
               </a:spcAft>
             </a:pPr>
             <a:r>
-              <a:rPr b="1" sz="1500">
+              <a:rPr sz="1500" b="1">
                 <a:solidFill>
                   <a:srgbClr val="0891B2"/>
                 </a:solidFill>
@@ -6004,7 +6016,7 @@
               <a:t>• </a:t>
             </a:r>
             <a:r>
-              <a:rPr b="1" sz="1500">
+              <a:rPr sz="1500" b="1">
                 <a:solidFill>
                   <a:srgbClr val="0F172A"/>
                 </a:solidFill>
@@ -6013,7 +6025,7 @@
               <a:t>Regulatory Compliance: </a:t>
             </a:r>
             <a:r>
-              <a:rPr b="0" sz="1400">
+              <a:rPr sz="1400" b="0">
                 <a:solidFill>
                   <a:srgbClr val="1E293B"/>
                 </a:solidFill>
@@ -6027,7 +6039,7 @@
     </p:spTree>
     <p:extLst>
       <p:ext uri="{BB962C8B-B14F-4D97-AF65-F5344CB8AC3E}">
-        <p14:creationId xmlns:p14="http://schemas.microsoft.com/office/powerpoint/2010/main" val="1912483354"/>
+        <p14:creationId xmlns:p14="http://schemas.microsoft.com/office/powerpoint/2010/main" xmlns="" val="1912483354"/>
       </p:ext>
     </p:extLst>
   </p:cSld>
@@ -6066,7 +6078,7 @@
           <a:blip r:embed="rId3">
             <a:extLst>
               <a:ext uri="{28A0092B-C50C-407E-A947-70E740481C1C}">
-                <a14:useLocalDpi xmlns:a14="http://schemas.microsoft.com/office/drawing/2010/main" val="0"/>
+                <a14:useLocalDpi xmlns:a14="http://schemas.microsoft.com/office/drawing/2010/main" xmlns="" val="0"/>
               </a:ext>
             </a:extLst>
           </a:blip>
@@ -6090,14 +6102,14 @@
           <a:effectLst/>
           <a:extLst>
             <a:ext uri="{909E8E84-426E-40DD-AFC4-6F175D3DCCD1}">
-              <a14:hiddenFill xmlns:a14="http://schemas.microsoft.com/office/drawing/2010/main">
+              <a14:hiddenFill xmlns:a14="http://schemas.microsoft.com/office/drawing/2010/main" xmlns="">
                 <a:solidFill>
                   <a:schemeClr val="accent1"/>
                 </a:solidFill>
               </a14:hiddenFill>
             </a:ext>
             <a:ext uri="{91240B29-F687-4F45-9708-019B960494DF}">
-              <a14:hiddenLine xmlns:a14="http://schemas.microsoft.com/office/drawing/2010/main" w="9525">
+              <a14:hiddenLine xmlns:a14="http://schemas.microsoft.com/office/drawing/2010/main" xmlns="" w="9525">
                 <a:solidFill>
                   <a:schemeClr val="tx1"/>
                 </a:solidFill>
@@ -6107,7 +6119,7 @@
               </a14:hiddenLine>
             </a:ext>
             <a:ext uri="{AF507438-7753-43E0-B8FC-AC1667EBCBE1}">
-              <a14:hiddenEffects xmlns:a14="http://schemas.microsoft.com/office/drawing/2010/main">
+              <a14:hiddenEffects xmlns:a14="http://schemas.microsoft.com/office/drawing/2010/main" xmlns="">
                 <a:effectLst>
                   <a:outerShdw dist="35921" dir="2700000" algn="ctr" rotWithShape="0">
                     <a:schemeClr val="bg2"/>
@@ -6144,7 +6156,7 @@
               <a:spcAft>
                 <a:spcPts val="800"/>
               </a:spcAft>
-              <a:defRPr b="1" sz="2800">
+              <a:defRPr sz="2800" b="1">
                 <a:solidFill>
                   <a:srgbClr val="0F172A"/>
                 </a:solidFill>
@@ -6162,7 +6174,7 @@
               </a:spcAft>
             </a:pPr>
             <a:r>
-              <a:rPr b="1" sz="1500">
+              <a:rPr sz="1500" b="1">
                 <a:solidFill>
                   <a:srgbClr val="0891B2"/>
                 </a:solidFill>
@@ -6170,7 +6182,7 @@
               <a:t>• </a:t>
             </a:r>
             <a:r>
-              <a:rPr b="1" sz="1500">
+              <a:rPr sz="1500" b="1">
                 <a:solidFill>
                   <a:srgbClr val="0F172A"/>
                 </a:solidFill>
@@ -6179,7 +6191,7 @@
               <a:t>Zero Sharps Mis-segregation: </a:t>
             </a:r>
             <a:r>
-              <a:rPr b="0" sz="1400">
+              <a:rPr sz="1400" b="0">
                 <a:solidFill>
                   <a:srgbClr val="1E293B"/>
                 </a:solidFill>
@@ -6195,7 +6207,7 @@
               </a:spcAft>
             </a:pPr>
             <a:r>
-              <a:rPr b="1" sz="1500">
+              <a:rPr sz="1500" b="1">
                 <a:solidFill>
                   <a:srgbClr val="0891B2"/>
                 </a:solidFill>
@@ -6203,7 +6215,7 @@
               <a:t>• </a:t>
             </a:r>
             <a:r>
-              <a:rPr b="1" sz="1500">
+              <a:rPr sz="1500" b="1">
                 <a:solidFill>
                   <a:srgbClr val="0F172A"/>
                 </a:solidFill>
@@ -6212,7 +6224,7 @@
               <a:t>85% Overflow Reduction: </a:t>
             </a:r>
             <a:r>
-              <a:rPr b="0" sz="1400">
+              <a:rPr sz="1400" b="0">
                 <a:solidFill>
                   <a:srgbClr val="1E293B"/>
                 </a:solidFill>
@@ -6228,7 +6240,7 @@
               </a:spcAft>
             </a:pPr>
             <a:r>
-              <a:rPr b="1" sz="1500">
+              <a:rPr sz="1500" b="1">
                 <a:solidFill>
                   <a:srgbClr val="0891B2"/>
                 </a:solidFill>
@@ -6236,7 +6248,7 @@
               <a:t>• </a:t>
             </a:r>
             <a:r>
-              <a:rPr b="1" sz="1500">
+              <a:rPr sz="1500" b="1">
                 <a:solidFill>
                   <a:srgbClr val="0F172A"/>
                 </a:solidFill>
@@ -6245,7 +6257,7 @@
               <a:t>100% Cryptographic Traceability: </a:t>
             </a:r>
             <a:r>
-              <a:rPr b="0" sz="1400">
+              <a:rPr sz="1400" b="0">
                 <a:solidFill>
                   <a:srgbClr val="1E293B"/>
                 </a:solidFill>
@@ -6261,7 +6273,7 @@
               </a:spcAft>
             </a:pPr>
             <a:r>
-              <a:rPr b="1" sz="1500">
+              <a:rPr sz="1500" b="1">
                 <a:solidFill>
                   <a:srgbClr val="0891B2"/>
                 </a:solidFill>
@@ -6269,7 +6281,7 @@
               <a:t>• </a:t>
             </a:r>
             <a:r>
-              <a:rPr b="1" sz="1500">
+              <a:rPr sz="1500" b="1">
                 <a:solidFill>
                   <a:srgbClr val="0F172A"/>
                 </a:solidFill>
@@ -6278,7 +6290,7 @@
               <a:t>Explainable Decision Audits: </a:t>
             </a:r>
             <a:r>
-              <a:rPr b="0" sz="1400">
+              <a:rPr sz="1400" b="0">
                 <a:solidFill>
                   <a:srgbClr val="1E293B"/>
                 </a:solidFill>
@@ -6294,7 +6306,7 @@
               </a:spcAft>
             </a:pPr>
             <a:r>
-              <a:rPr b="1" sz="1500">
+              <a:rPr sz="1500" b="1">
                 <a:solidFill>
                   <a:srgbClr val="0891B2"/>
                 </a:solidFill>
@@ -6302,7 +6314,7 @@
               <a:t>• </a:t>
             </a:r>
             <a:r>
-              <a:rPr b="1" sz="1500">
+              <a:rPr sz="1500" b="1">
                 <a:solidFill>
                   <a:srgbClr val="0F172A"/>
                 </a:solidFill>
@@ -6311,7 +6323,7 @@
               <a:t>Continuous Model Learning: </a:t>
             </a:r>
             <a:r>
-              <a:rPr b="0" sz="1400">
+              <a:rPr sz="1400" b="0">
                 <a:solidFill>
                   <a:srgbClr val="1E293B"/>
                 </a:solidFill>
@@ -6325,7 +6337,7 @@
     </p:spTree>
     <p:extLst>
       <p:ext uri="{BB962C8B-B14F-4D97-AF65-F5344CB8AC3E}">
-        <p14:creationId xmlns:p14="http://schemas.microsoft.com/office/powerpoint/2010/main" val="1912483354"/>
+        <p14:creationId xmlns:p14="http://schemas.microsoft.com/office/powerpoint/2010/main" xmlns="" val="1912483354"/>
       </p:ext>
     </p:extLst>
   </p:cSld>
@@ -6364,7 +6376,7 @@
           <a:blip r:embed="rId3">
             <a:extLst>
               <a:ext uri="{28A0092B-C50C-407E-A947-70E740481C1C}">
-                <a14:useLocalDpi xmlns:a14="http://schemas.microsoft.com/office/drawing/2010/main" val="0"/>
+                <a14:useLocalDpi xmlns:a14="http://schemas.microsoft.com/office/drawing/2010/main" xmlns="" val="0"/>
               </a:ext>
             </a:extLst>
           </a:blip>
@@ -6388,14 +6400,14 @@
           <a:effectLst/>
           <a:extLst>
             <a:ext uri="{909E8E84-426E-40DD-AFC4-6F175D3DCCD1}">
-              <a14:hiddenFill xmlns:a14="http://schemas.microsoft.com/office/drawing/2010/main">
+              <a14:hiddenFill xmlns:a14="http://schemas.microsoft.com/office/drawing/2010/main" xmlns="">
                 <a:solidFill>
                   <a:schemeClr val="accent1"/>
                 </a:solidFill>
               </a14:hiddenFill>
             </a:ext>
             <a:ext uri="{91240B29-F687-4F45-9708-019B960494DF}">
-              <a14:hiddenLine xmlns:a14="http://schemas.microsoft.com/office/drawing/2010/main" w="9525">
+              <a14:hiddenLine xmlns:a14="http://schemas.microsoft.com/office/drawing/2010/main" xmlns="" w="9525">
                 <a:solidFill>
                   <a:schemeClr val="tx1"/>
                 </a:solidFill>
@@ -6405,7 +6417,7 @@
               </a14:hiddenLine>
             </a:ext>
             <a:ext uri="{AF507438-7753-43E0-B8FC-AC1667EBCBE1}">
-              <a14:hiddenEffects xmlns:a14="http://schemas.microsoft.com/office/drawing/2010/main">
+              <a14:hiddenEffects xmlns:a14="http://schemas.microsoft.com/office/drawing/2010/main" xmlns="">
                 <a:effectLst>
                   <a:outerShdw dist="35921" dir="2700000" algn="ctr" rotWithShape="0">
                     <a:schemeClr val="bg2"/>
@@ -6442,7 +6454,7 @@
               <a:spcAft>
                 <a:spcPts val="800"/>
               </a:spcAft>
-              <a:defRPr b="1" sz="2800">
+              <a:defRPr sz="2800" b="1">
                 <a:solidFill>
                   <a:srgbClr val="0F172A"/>
                 </a:solidFill>
@@ -6458,7 +6470,7 @@
               <a:spcAft>
                 <a:spcPts val="1600"/>
               </a:spcAft>
-              <a:defRPr b="1" sz="1600">
+              <a:defRPr sz="1600" b="1">
                 <a:solidFill>
                   <a:srgbClr val="0891B2"/>
                 </a:solidFill>
@@ -6476,7 +6488,7 @@
               </a:spcAft>
             </a:pPr>
             <a:r>
-              <a:rPr b="1" sz="1500">
+              <a:rPr sz="1500" b="1">
                 <a:solidFill>
                   <a:srgbClr val="0891B2"/>
                 </a:solidFill>
@@ -6484,7 +6496,7 @@
               <a:t>• </a:t>
             </a:r>
             <a:r>
-              <a:rPr b="1" sz="1500">
+              <a:rPr sz="1500" b="1">
                 <a:solidFill>
                   <a:srgbClr val="0F172A"/>
                 </a:solidFill>
@@ -6493,7 +6505,7 @@
               <a:t>Problem Statement ID: </a:t>
             </a:r>
             <a:r>
-              <a:rPr b="0" sz="1400">
+              <a:rPr sz="1400" b="0">
                 <a:solidFill>
                   <a:srgbClr val="1E293B"/>
                 </a:solidFill>
@@ -6509,7 +6521,7 @@
               </a:spcAft>
             </a:pPr>
             <a:r>
-              <a:rPr b="1" sz="1500">
+              <a:rPr sz="1500" b="1">
                 <a:solidFill>
                   <a:srgbClr val="0891B2"/>
                 </a:solidFill>
@@ -6517,7 +6529,7 @@
               <a:t>• </a:t>
             </a:r>
             <a:r>
-              <a:rPr b="1" sz="1500">
+              <a:rPr sz="1500" b="1">
                 <a:solidFill>
                   <a:srgbClr val="0F172A"/>
                 </a:solidFill>
@@ -6526,7 +6538,7 @@
               <a:t>Live Application Server: </a:t>
             </a:r>
             <a:r>
-              <a:rPr b="0" sz="1400">
+              <a:rPr sz="1400" b="0">
                 <a:solidFill>
                   <a:srgbClr val="1E293B"/>
                 </a:solidFill>
@@ -6542,7 +6554,7 @@
               </a:spcAft>
             </a:pPr>
             <a:r>
-              <a:rPr b="1" sz="1500">
+              <a:rPr sz="1500" b="1">
                 <a:solidFill>
                   <a:srgbClr val="0891B2"/>
                 </a:solidFill>
@@ -6550,7 +6562,7 @@
               <a:t>• </a:t>
             </a:r>
             <a:r>
-              <a:rPr b="1" sz="1500">
+              <a:rPr sz="1500" b="1">
                 <a:solidFill>
                   <a:srgbClr val="0F172A"/>
                 </a:solidFill>
@@ -6559,7 +6571,7 @@
               <a:t>Public Tunnel Link: </a:t>
             </a:r>
             <a:r>
-              <a:rPr b="0" sz="1400">
+              <a:rPr sz="1400" b="0">
                 <a:solidFill>
                   <a:srgbClr val="1E293B"/>
                 </a:solidFill>
@@ -6575,7 +6587,7 @@
               </a:spcAft>
             </a:pPr>
             <a:r>
-              <a:rPr b="1" sz="1500">
+              <a:rPr sz="1500" b="1">
                 <a:solidFill>
                   <a:srgbClr val="0891B2"/>
                 </a:solidFill>
@@ -6583,7 +6595,7 @@
               <a:t>• </a:t>
             </a:r>
             <a:r>
-              <a:rPr b="1" sz="1500">
+              <a:rPr sz="1500" b="1">
                 <a:solidFill>
                   <a:srgbClr val="0F172A"/>
                 </a:solidFill>
@@ -6592,7 +6604,7 @@
               <a:t>GitHub Repository: </a:t>
             </a:r>
             <a:r>
-              <a:rPr b="0" sz="1400">
+              <a:rPr sz="1400" b="0">
                 <a:solidFill>
                   <a:srgbClr val="1E293B"/>
                 </a:solidFill>
@@ -6608,7 +6620,7 @@
               </a:spcAft>
             </a:pPr>
             <a:r>
-              <a:rPr b="1" sz="1500">
+              <a:rPr sz="1500" b="1">
                 <a:solidFill>
                   <a:srgbClr val="0891B2"/>
                 </a:solidFill>
@@ -6616,7 +6628,7 @@
               <a:t>• </a:t>
             </a:r>
             <a:r>
-              <a:rPr b="1" sz="1500">
+              <a:rPr sz="1500" b="1">
                 <a:solidFill>
                   <a:srgbClr val="0F172A"/>
                 </a:solidFill>
@@ -6625,7 +6637,7 @@
               <a:t>Questions &amp; Discussion: </a:t>
             </a:r>
             <a:r>
-              <a:rPr b="0" sz="1400">
+              <a:rPr sz="1400" b="0">
                 <a:solidFill>
                   <a:srgbClr val="1E293B"/>
                 </a:solidFill>
@@ -6639,7 +6651,7 @@
     </p:spTree>
     <p:extLst>
       <p:ext uri="{BB962C8B-B14F-4D97-AF65-F5344CB8AC3E}">
-        <p14:creationId xmlns:p14="http://schemas.microsoft.com/office/powerpoint/2010/main" val="1912483354"/>
+        <p14:creationId xmlns:p14="http://schemas.microsoft.com/office/powerpoint/2010/main" xmlns="" val="1912483354"/>
       </p:ext>
     </p:extLst>
   </p:cSld>
@@ -7286,11 +7298,12 @@
 </file>
 
 <file path=customXml/item1.xml><?xml version="1.0" encoding="utf-8"?>
-<p:properties xmlns:p="http://schemas.microsoft.com/office/2006/metadata/properties" xmlns:xsi="http://www.w3.org/2001/XMLSchema-instance" xmlns:pc="http://schemas.microsoft.com/office/infopath/2007/PartnerControls">
-  <documentManagement>
-    <_activity xmlns="bfbf4f4c-bfad-413d-b344-4db2c8587354" xsi:nil="true"/>
-  </documentManagement>
-</p:properties>
+<?mso-contentType ?>
+<FormTemplates xmlns="http://schemas.microsoft.com/sharepoint/v3/contenttype/forms">
+  <Display>DocumentLibraryForm</Display>
+  <Edit>DocumentLibraryForm</Edit>
+  <New>DocumentLibraryForm</New>
+</FormTemplates>
 </file>
 
 <file path=customXml/item2.xml><?xml version="1.0" encoding="utf-8"?>
@@ -7450,26 +7463,17 @@
 </file>
 
 <file path=customXml/item3.xml><?xml version="1.0" encoding="utf-8"?>
-<?mso-contentType ?>
-<FormTemplates xmlns="http://schemas.microsoft.com/sharepoint/v3/contenttype/forms">
-  <Display>DocumentLibraryForm</Display>
-  <Edit>DocumentLibraryForm</Edit>
-  <New>DocumentLibraryForm</New>
-</FormTemplates>
+<p:properties xmlns:p="http://schemas.microsoft.com/office/2006/metadata/properties" xmlns:xsi="http://www.w3.org/2001/XMLSchema-instance" xmlns:pc="http://schemas.microsoft.com/office/infopath/2007/PartnerControls">
+  <documentManagement>
+    <_activity xmlns="bfbf4f4c-bfad-413d-b344-4db2c8587354" xsi:nil="true"/>
+  </documentManagement>
+</p:properties>
 </file>
 
 <file path=customXml/itemProps1.xml><?xml version="1.0" encoding="utf-8"?>
-<ds:datastoreItem xmlns:ds="http://schemas.openxmlformats.org/officeDocument/2006/customXml" ds:itemID="{DB14BFA1-01D7-4453-9DB4-8F8A2678992B}">
+<ds:datastoreItem xmlns:ds="http://schemas.openxmlformats.org/officeDocument/2006/customXml" ds:itemID="{FFC810CB-D5CE-4F3B-8EE4-8F18EAA0D46F}">
   <ds:schemaRefs>
-    <ds:schemaRef ds:uri="http://purl.org/dc/terms/"/>
-    <ds:schemaRef ds:uri="http://schemas.microsoft.com/office/2006/metadata/properties"/>
-    <ds:schemaRef ds:uri="http://schemas.microsoft.com/office/2006/documentManagement/types"/>
-    <ds:schemaRef ds:uri="http://purl.org/dc/elements/1.1/"/>
-    <ds:schemaRef ds:uri="http://schemas.microsoft.com/office/infopath/2007/PartnerControls"/>
-    <ds:schemaRef ds:uri="http://schemas.openxmlformats.org/package/2006/metadata/core-properties"/>
-    <ds:schemaRef ds:uri="bfbf4f4c-bfad-413d-b344-4db2c8587354"/>
-    <ds:schemaRef ds:uri="http://www.w3.org/XML/1998/namespace"/>
-    <ds:schemaRef ds:uri="http://purl.org/dc/dcmitype/"/>
+    <ds:schemaRef ds:uri="http://schemas.microsoft.com/sharepoint/v3/contenttype/forms"/>
   </ds:schemaRefs>
 </ds:datastoreItem>
 </file>
@@ -7493,9 +7497,17 @@
 </file>
 
 <file path=customXml/itemProps3.xml><?xml version="1.0" encoding="utf-8"?>
-<ds:datastoreItem xmlns:ds="http://schemas.openxmlformats.org/officeDocument/2006/customXml" ds:itemID="{FFC810CB-D5CE-4F3B-8EE4-8F18EAA0D46F}">
+<ds:datastoreItem xmlns:ds="http://schemas.openxmlformats.org/officeDocument/2006/customXml" ds:itemID="{DB14BFA1-01D7-4453-9DB4-8F8A2678992B}">
   <ds:schemaRefs>
-    <ds:schemaRef ds:uri="http://schemas.microsoft.com/sharepoint/v3/contenttype/forms"/>
+    <ds:schemaRef ds:uri="http://purl.org/dc/terms/"/>
+    <ds:schemaRef ds:uri="http://schemas.microsoft.com/office/2006/metadata/properties"/>
+    <ds:schemaRef ds:uri="http://schemas.microsoft.com/office/2006/documentManagement/types"/>
+    <ds:schemaRef ds:uri="http://purl.org/dc/elements/1.1/"/>
+    <ds:schemaRef ds:uri="http://schemas.microsoft.com/office/infopath/2007/PartnerControls"/>
+    <ds:schemaRef ds:uri="http://schemas.openxmlformats.org/package/2006/metadata/core-properties"/>
+    <ds:schemaRef ds:uri="bfbf4f4c-bfad-413d-b344-4db2c8587354"/>
+    <ds:schemaRef ds:uri="http://www.w3.org/XML/1998/namespace"/>
+    <ds:schemaRef ds:uri="http://purl.org/dc/dcmitype/"/>
   </ds:schemaRefs>
 </ds:datastoreItem>
 </file>
</xml_diff>